<commit_message>
feat: let evidence choose the agent composition
</commit_message>
<xml_diff>
--- a/submission/ChronosFix_90秒答辩版.pptx
+++ b/submission/ChronosFix_90秒答辩版.pptx
@@ -2,18 +2,18 @@
 <file path=ppt/presentation.xml><?xml version="1.0" encoding="utf-8"?>
 <p:presentation xmlns:p="http://schemas.openxmlformats.org/presentationml/2006/main">
   <p:sldMasterIdLst>
-    <p:sldMasterId xmlns:r="http://schemas.openxmlformats.org/officeDocument/2006/relationships" id="2147483648" r:id="R6be743d2c9204a1b"/>
+    <p:sldMasterId xmlns:r="http://schemas.openxmlformats.org/officeDocument/2006/relationships" id="2147483648" r:id="R605b0b9a74944a2a"/>
   </p:sldMasterIdLst>
   <p:notesMasterIdLst>
-    <p:notesMasterId xmlns:r="http://schemas.openxmlformats.org/officeDocument/2006/relationships" r:id="R434c1ed28946462c"/>
+    <p:notesMasterId xmlns:r="http://schemas.openxmlformats.org/officeDocument/2006/relationships" r:id="Rf508e9f97e304d3a"/>
   </p:notesMasterIdLst>
   <p:sldIdLst>
-    <p:sldId xmlns:r="http://schemas.openxmlformats.org/officeDocument/2006/relationships" id="256" r:id="R791c99a4d1004c5d"/>
-    <p:sldId xmlns:r="http://schemas.openxmlformats.org/officeDocument/2006/relationships" id="257" r:id="Rae181c6d9e294a2d"/>
-    <p:sldId xmlns:r="http://schemas.openxmlformats.org/officeDocument/2006/relationships" id="258" r:id="R8e9786ba8c0744dd"/>
-    <p:sldId xmlns:r="http://schemas.openxmlformats.org/officeDocument/2006/relationships" id="259" r:id="Rece0b63959894d76"/>
-    <p:sldId xmlns:r="http://schemas.openxmlformats.org/officeDocument/2006/relationships" id="260" r:id="R8cba1aa9bbec4f68"/>
-    <p:sldId xmlns:r="http://schemas.openxmlformats.org/officeDocument/2006/relationships" id="261" r:id="R8ce29eaf43c14f6e"/>
+    <p:sldId xmlns:r="http://schemas.openxmlformats.org/officeDocument/2006/relationships" id="256" r:id="Ra63b997af22a4822"/>
+    <p:sldId xmlns:r="http://schemas.openxmlformats.org/officeDocument/2006/relationships" id="257" r:id="R960c32d810d64197"/>
+    <p:sldId xmlns:r="http://schemas.openxmlformats.org/officeDocument/2006/relationships" id="258" r:id="R0e87c52238604f6e"/>
+    <p:sldId xmlns:r="http://schemas.openxmlformats.org/officeDocument/2006/relationships" id="259" r:id="R53faab5c8a254ff4"/>
+    <p:sldId xmlns:r="http://schemas.openxmlformats.org/officeDocument/2006/relationships" id="260" r:id="R62c0ec9ac3ba4064"/>
+    <p:sldId xmlns:r="http://schemas.openxmlformats.org/officeDocument/2006/relationships" id="261" r:id="R85cb786e8c534aec"/>
   </p:sldIdLst>
   <p:sldSz cx="12192000" cy="6858000"/>
   <p:notesSz cx="6858000" cy="9144000"/>
@@ -975,7 +975,7 @@
   </p:cSld>
   <p:clrMap bg1="lt1" tx1="dk1" bg2="lt2" tx2="dk2" accent1="accent1" accent2="accent2" accent3="accent3" accent4="accent4" accent5="accent5" accent6="accent6" hlink="hlink" folHlink="folHlink"/>
   <p:sldLayoutIdLst>
-    <p:sldLayoutId xmlns:r="http://schemas.openxmlformats.org/officeDocument/2006/relationships" id="2147483649" r:id="R4be69e26b4d4409e"/>
+    <p:sldLayoutId xmlns:r="http://schemas.openxmlformats.org/officeDocument/2006/relationships" id="2147483649" r:id="R1377dcc39cff4cd7"/>
   </p:sldLayoutIdLst>
   <p:txStyles>
     <p:titleStyle>
@@ -3774,7 +3774,7 @@
                   <a:srgbClr val="16A34A"/>
                 </a:solidFill>
               </a:rPr>
-              <a:t>54</a:t>
+              <a:t>57</a:t>
             </a:r>
           </a:p>
         </p:txBody>
@@ -4160,7 +4160,7 @@
                   <a:srgbClr val="64748B"/>
                 </a:solidFill>
               </a:rPr>
-              <a:t>8 个逻辑 Worker、备份实例、PID、duration_ms、SQLite Matrix；官方 AgentTeams 仍明确标 pending。</a:t>
+              <a:t>Manager 根据证据自由组合 Agent/Skill；本地 Controller 记录 PID、duration_ms、SQLite Matrix，官方 AgentTeams 仍明确标 pending。</a:t>
             </a:r>
           </a:p>
         </p:txBody>

</xml_diff>

<commit_message>
release: align semifinal artifact counts
</commit_message>
<xml_diff>
--- a/submission/ChronosFix_90秒答辩版.pptx
+++ b/submission/ChronosFix_90秒答辩版.pptx
@@ -2,18 +2,18 @@
 <file path=ppt/presentation.xml><?xml version="1.0" encoding="utf-8"?>
 <p:presentation xmlns:p="http://schemas.openxmlformats.org/presentationml/2006/main">
   <p:sldMasterIdLst>
-    <p:sldMasterId xmlns:r="http://schemas.openxmlformats.org/officeDocument/2006/relationships" id="2147483648" r:id="R605b0b9a74944a2a"/>
+    <p:sldMasterId xmlns:r="http://schemas.openxmlformats.org/officeDocument/2006/relationships" id="2147483648" r:id="R92a2854b73dd46c7"/>
   </p:sldMasterIdLst>
   <p:notesMasterIdLst>
-    <p:notesMasterId xmlns:r="http://schemas.openxmlformats.org/officeDocument/2006/relationships" r:id="Rf508e9f97e304d3a"/>
+    <p:notesMasterId xmlns:r="http://schemas.openxmlformats.org/officeDocument/2006/relationships" r:id="Rb77e2476fd68434a"/>
   </p:notesMasterIdLst>
   <p:sldIdLst>
-    <p:sldId xmlns:r="http://schemas.openxmlformats.org/officeDocument/2006/relationships" id="256" r:id="Ra63b997af22a4822"/>
-    <p:sldId xmlns:r="http://schemas.openxmlformats.org/officeDocument/2006/relationships" id="257" r:id="R960c32d810d64197"/>
-    <p:sldId xmlns:r="http://schemas.openxmlformats.org/officeDocument/2006/relationships" id="258" r:id="R0e87c52238604f6e"/>
-    <p:sldId xmlns:r="http://schemas.openxmlformats.org/officeDocument/2006/relationships" id="259" r:id="R53faab5c8a254ff4"/>
-    <p:sldId xmlns:r="http://schemas.openxmlformats.org/officeDocument/2006/relationships" id="260" r:id="R62c0ec9ac3ba4064"/>
-    <p:sldId xmlns:r="http://schemas.openxmlformats.org/officeDocument/2006/relationships" id="261" r:id="R85cb786e8c534aec"/>
+    <p:sldId xmlns:r="http://schemas.openxmlformats.org/officeDocument/2006/relationships" id="256" r:id="R82102e28fc1a48b7"/>
+    <p:sldId xmlns:r="http://schemas.openxmlformats.org/officeDocument/2006/relationships" id="257" r:id="R3e327d96452d4056"/>
+    <p:sldId xmlns:r="http://schemas.openxmlformats.org/officeDocument/2006/relationships" id="258" r:id="Rf93499a5de6a437e"/>
+    <p:sldId xmlns:r="http://schemas.openxmlformats.org/officeDocument/2006/relationships" id="259" r:id="R868a526d51734c93"/>
+    <p:sldId xmlns:r="http://schemas.openxmlformats.org/officeDocument/2006/relationships" id="260" r:id="Re76dbae6390b4fe0"/>
+    <p:sldId xmlns:r="http://schemas.openxmlformats.org/officeDocument/2006/relationships" id="261" r:id="R6df5bedacb6e4d02"/>
   </p:sldIdLst>
   <p:sldSz cx="12192000" cy="6858000"/>
   <p:notesSz cx="6858000" cy="9144000"/>
@@ -532,7 +532,7 @@
           <a:lstStyle xmlns:a="http://schemas.openxmlformats.org/drawingml/2006/main"/>
           <a:p xmlns:a="http://schemas.openxmlformats.org/drawingml/2006/main">
             <a:r>
-              <a:t>0:12–0:27 先讲结果：48.72% 到 6.25% 的既有评测口径、8 个强制故障变体、14 条证据声明；新增本地真实执行与 54 项测试。</a:t>
+              <a:t>0:12–0:27 先讲结果：48.72% 到 6.25% 的既有评测口径、8 个强制故障变体、14 条证据声明；新增本地真实执行与 61 项测试。</a:t>
             </a:r>
           </a:p>
           <a:p xmlns:a="http://schemas.openxmlformats.org/drawingml/2006/main">
@@ -547,7 +547,7 @@
           </a:p>
           <a:p xmlns:a="http://schemas.openxmlformats.org/drawingml/2006/main">
             <a:r>
-              <a:t>- Internal: tests/ (pytest collection: 54)</a:t>
+              <a:t>- Internal: tests/ (pytest collection: 61)</a:t>
             </a:r>
           </a:p>
         </p:txBody>
@@ -975,7 +975,7 @@
   </p:cSld>
   <p:clrMap bg1="lt1" tx1="dk1" bg2="lt2" tx2="dk2" accent1="accent1" accent2="accent2" accent3="accent3" accent4="accent4" accent5="accent5" accent6="accent6" hlink="hlink" folHlink="folHlink"/>
   <p:sldLayoutIdLst>
-    <p:sldLayoutId xmlns:r="http://schemas.openxmlformats.org/officeDocument/2006/relationships" id="2147483649" r:id="R1377dcc39cff4cd7"/>
+    <p:sldLayoutId xmlns:r="http://schemas.openxmlformats.org/officeDocument/2006/relationships" id="2147483649" r:id="R5efafa4699a547a4"/>
   </p:sldLayoutIdLst>
   <p:txStyles>
     <p:titleStyle>
@@ -3774,7 +3774,7 @@
                   <a:srgbClr val="16A34A"/>
                 </a:solidFill>
               </a:rPr>
-              <a:t>57</a:t>
+              <a:t>61</a:t>
             </a:r>
           </a:p>
         </p:txBody>

</xml_diff>

<commit_message>
fix: restore official ChronosFix work title
</commit_message>
<xml_diff>
--- a/submission/ChronosFix_90秒答辩版.pptx
+++ b/submission/ChronosFix_90秒答辩版.pptx
@@ -2,18 +2,18 @@
 <file path=ppt/presentation.xml><?xml version="1.0" encoding="utf-8"?>
 <p:presentation xmlns:p="http://schemas.openxmlformats.org/presentationml/2006/main">
   <p:sldMasterIdLst>
-    <p:sldMasterId xmlns:r="http://schemas.openxmlformats.org/officeDocument/2006/relationships" id="2147483648" r:id="R92a2854b73dd46c7"/>
+    <p:sldMasterId xmlns:r="http://schemas.openxmlformats.org/officeDocument/2006/relationships" id="2147483648" r:id="R9e0d5f4b20114693"/>
   </p:sldMasterIdLst>
   <p:notesMasterIdLst>
-    <p:notesMasterId xmlns:r="http://schemas.openxmlformats.org/officeDocument/2006/relationships" r:id="Rb77e2476fd68434a"/>
+    <p:notesMasterId xmlns:r="http://schemas.openxmlformats.org/officeDocument/2006/relationships" r:id="Rf864faa5d0ed4d4b"/>
   </p:notesMasterIdLst>
   <p:sldIdLst>
-    <p:sldId xmlns:r="http://schemas.openxmlformats.org/officeDocument/2006/relationships" id="256" r:id="R82102e28fc1a48b7"/>
-    <p:sldId xmlns:r="http://schemas.openxmlformats.org/officeDocument/2006/relationships" id="257" r:id="R3e327d96452d4056"/>
-    <p:sldId xmlns:r="http://schemas.openxmlformats.org/officeDocument/2006/relationships" id="258" r:id="Rf93499a5de6a437e"/>
-    <p:sldId xmlns:r="http://schemas.openxmlformats.org/officeDocument/2006/relationships" id="259" r:id="R868a526d51734c93"/>
-    <p:sldId xmlns:r="http://schemas.openxmlformats.org/officeDocument/2006/relationships" id="260" r:id="Re76dbae6390b4fe0"/>
-    <p:sldId xmlns:r="http://schemas.openxmlformats.org/officeDocument/2006/relationships" id="261" r:id="R6df5bedacb6e4d02"/>
+    <p:sldId xmlns:r="http://schemas.openxmlformats.org/officeDocument/2006/relationships" id="256" r:id="Re2cc5e838634463c"/>
+    <p:sldId xmlns:r="http://schemas.openxmlformats.org/officeDocument/2006/relationships" id="257" r:id="Rc260233299b04f73"/>
+    <p:sldId xmlns:r="http://schemas.openxmlformats.org/officeDocument/2006/relationships" id="258" r:id="Rfce5074c678145de"/>
+    <p:sldId xmlns:r="http://schemas.openxmlformats.org/officeDocument/2006/relationships" id="259" r:id="R37ef13fdb15c4ee4"/>
+    <p:sldId xmlns:r="http://schemas.openxmlformats.org/officeDocument/2006/relationships" id="260" r:id="R06c035193fda448d"/>
+    <p:sldId xmlns:r="http://schemas.openxmlformats.org/officeDocument/2006/relationships" id="261" r:id="R1ff36fbc0f384f45"/>
   </p:sldIdLst>
   <p:sldSz cx="12192000" cy="6858000"/>
   <p:notesSz cx="6858000" cy="9144000"/>
@@ -975,7 +975,7 @@
   </p:cSld>
   <p:clrMap bg1="lt1" tx1="dk1" bg2="lt2" tx2="dk2" accent1="accent1" accent2="accent2" accent3="accent3" accent4="accent4" accent5="accent5" accent6="accent6" hlink="hlink" folHlink="folHlink"/>
   <p:sldLayoutIdLst>
-    <p:sldLayoutId xmlns:r="http://schemas.openxmlformats.org/officeDocument/2006/relationships" id="2147483649" r:id="R5efafa4699a547a4"/>
+    <p:sldLayoutId xmlns:r="http://schemas.openxmlformats.org/officeDocument/2006/relationships" id="2147483649" r:id="R2a8e96b704bf4b17"/>
   </p:sldLayoutIdLst>
   <p:txStyles>
     <p:titleStyle>
@@ -1700,7 +1700,7 @@
                   <a:srgbClr val="FFFFFF"/>
                 </a:solidFill>
               </a:rPr>
-              <a:t>带证据的软件修复引擎</a:t>
+              <a:t>A-CFX：软件故障时间机器</a:t>
             </a:r>
           </a:p>
         </p:txBody>

</xml_diff>

<commit_message>
feat: add incremental causal recompute
</commit_message>
<xml_diff>
--- a/submission/ChronosFix_90秒答辩版.pptx
+++ b/submission/ChronosFix_90秒答辩版.pptx
@@ -2,18 +2,18 @@
 <file path=ppt/presentation.xml><?xml version="1.0" encoding="utf-8"?>
 <p:presentation xmlns:p="http://schemas.openxmlformats.org/presentationml/2006/main">
   <p:sldMasterIdLst>
-    <p:sldMasterId xmlns:r="http://schemas.openxmlformats.org/officeDocument/2006/relationships" id="2147483648" r:id="R9e0d5f4b20114693"/>
+    <p:sldMasterId xmlns:r="http://schemas.openxmlformats.org/officeDocument/2006/relationships" id="2147483648" r:id="Rac59007da92c418e"/>
   </p:sldMasterIdLst>
   <p:notesMasterIdLst>
-    <p:notesMasterId xmlns:r="http://schemas.openxmlformats.org/officeDocument/2006/relationships" r:id="Rf864faa5d0ed4d4b"/>
+    <p:notesMasterId xmlns:r="http://schemas.openxmlformats.org/officeDocument/2006/relationships" r:id="Rad0d85fe3ee04823"/>
   </p:notesMasterIdLst>
   <p:sldIdLst>
-    <p:sldId xmlns:r="http://schemas.openxmlformats.org/officeDocument/2006/relationships" id="256" r:id="Re2cc5e838634463c"/>
-    <p:sldId xmlns:r="http://schemas.openxmlformats.org/officeDocument/2006/relationships" id="257" r:id="Rc260233299b04f73"/>
-    <p:sldId xmlns:r="http://schemas.openxmlformats.org/officeDocument/2006/relationships" id="258" r:id="Rfce5074c678145de"/>
-    <p:sldId xmlns:r="http://schemas.openxmlformats.org/officeDocument/2006/relationships" id="259" r:id="R37ef13fdb15c4ee4"/>
-    <p:sldId xmlns:r="http://schemas.openxmlformats.org/officeDocument/2006/relationships" id="260" r:id="R06c035193fda448d"/>
-    <p:sldId xmlns:r="http://schemas.openxmlformats.org/officeDocument/2006/relationships" id="261" r:id="R1ff36fbc0f384f45"/>
+    <p:sldId xmlns:r="http://schemas.openxmlformats.org/officeDocument/2006/relationships" id="256" r:id="R91eca870086e424f"/>
+    <p:sldId xmlns:r="http://schemas.openxmlformats.org/officeDocument/2006/relationships" id="257" r:id="R7cd793fea8db4922"/>
+    <p:sldId xmlns:r="http://schemas.openxmlformats.org/officeDocument/2006/relationships" id="258" r:id="Rf3098d49a0f3458e"/>
+    <p:sldId xmlns:r="http://schemas.openxmlformats.org/officeDocument/2006/relationships" id="259" r:id="R18fb6fea776c4979"/>
+    <p:sldId xmlns:r="http://schemas.openxmlformats.org/officeDocument/2006/relationships" id="260" r:id="R1f9156865a364a70"/>
+    <p:sldId xmlns:r="http://schemas.openxmlformats.org/officeDocument/2006/relationships" id="261" r:id="R64ee601f77304c52"/>
   </p:sldIdLst>
   <p:sldSz cx="12192000" cy="6858000"/>
   <p:notesSz cx="6858000" cy="9144000"/>
@@ -532,7 +532,7 @@
           <a:lstStyle xmlns:a="http://schemas.openxmlformats.org/drawingml/2006/main"/>
           <a:p xmlns:a="http://schemas.openxmlformats.org/drawingml/2006/main">
             <a:r>
-              <a:t>0:12–0:27 先讲结果：48.72% 到 6.25% 的既有评测口径、8 个强制故障变体、14 条证据声明；新增本地真实执行与 61 项测试。</a:t>
+              <a:t>0:12–0:27 先讲结果：48.72% 到 6.25% 的既有评测口径、8 个强制故障变体、14 条证据声明；新增本地真实执行、Agent DAG、增量因果重算与 66 项测试。</a:t>
             </a:r>
           </a:p>
           <a:p xmlns:a="http://schemas.openxmlformats.org/drawingml/2006/main">
@@ -547,7 +547,7 @@
           </a:p>
           <a:p xmlns:a="http://schemas.openxmlformats.org/drawingml/2006/main">
             <a:r>
-              <a:t>- Internal: tests/ (pytest collection: 61)</a:t>
+              <a:t>- Internal: tests/ (unittest collection: 66)</a:t>
             </a:r>
           </a:p>
         </p:txBody>
@@ -975,7 +975,7 @@
   </p:cSld>
   <p:clrMap bg1="lt1" tx1="dk1" bg2="lt2" tx2="dk2" accent1="accent1" accent2="accent2" accent3="accent3" accent4="accent4" accent5="accent5" accent6="accent6" hlink="hlink" folHlink="folHlink"/>
   <p:sldLayoutIdLst>
-    <p:sldLayoutId xmlns:r="http://schemas.openxmlformats.org/officeDocument/2006/relationships" id="2147483649" r:id="R2a8e96b704bf4b17"/>
+    <p:sldLayoutId xmlns:r="http://schemas.openxmlformats.org/officeDocument/2006/relationships" id="2147483649" r:id="Ra208074a65614cdb"/>
   </p:sldLayoutIdLst>
   <p:txStyles>
     <p:titleStyle>
@@ -3774,7 +3774,7 @@
                   <a:srgbClr val="16A34A"/>
                 </a:solidFill>
               </a:rPr>
-              <a:t>61</a:t>
+              <a:t>66</a:t>
             </a:r>
           </a:p>
         </p:txBody>
@@ -4160,7 +4160,7 @@
                   <a:srgbClr val="64748B"/>
                 </a:solidFill>
               </a:rPr>
-              <a:t>Manager 根据证据自由组合 Agent/Skill；本地 Controller 记录 PID、duration_ms、SQLite Matrix，官方 AgentTeams 仍明确标 pending。</a:t>
+              <a:t>Manager 根据证据自由组合 Agent/Skill；新证据触发增量因果重算，本地 Controller 记录 PID、duration_ms、SQLite Matrix，官方 AgentTeams 仍明确标 pending。</a:t>
             </a:r>
           </a:p>
         </p:txBody>
@@ -7084,7 +7084,7 @@
                   <a:srgbClr val="64748B"/>
                 </a:solidFill>
               </a:rPr>
-              <a:t>Worker 失败重派｜新证据插入｜旧审批失效｜Badcase 拒答</a:t>
+              <a:t>Worker 失败重派｜增量因果重算｜旧审批失效｜Badcase 拒答</a:t>
             </a:r>
           </a:p>
         </p:txBody>

</xml_diff>

<commit_message>
release: sync final defense artifacts
</commit_message>
<xml_diff>
--- a/submission/ChronosFix_90秒答辩版.pptx
+++ b/submission/ChronosFix_90秒答辩版.pptx
@@ -2,18 +2,18 @@
 <file path=ppt/presentation.xml><?xml version="1.0" encoding="utf-8"?>
 <p:presentation xmlns:p="http://schemas.openxmlformats.org/presentationml/2006/main">
   <p:sldMasterIdLst>
-    <p:sldMasterId xmlns:r="http://schemas.openxmlformats.org/officeDocument/2006/relationships" id="2147483648" r:id="Rac59007da92c418e"/>
+    <p:sldMasterId xmlns:r="http://schemas.openxmlformats.org/officeDocument/2006/relationships" id="2147483648" r:id="R40daaee0e70e4c4e"/>
   </p:sldMasterIdLst>
   <p:notesMasterIdLst>
-    <p:notesMasterId xmlns:r="http://schemas.openxmlformats.org/officeDocument/2006/relationships" r:id="Rad0d85fe3ee04823"/>
+    <p:notesMasterId xmlns:r="http://schemas.openxmlformats.org/officeDocument/2006/relationships" r:id="R2c4539afd7a24913"/>
   </p:notesMasterIdLst>
   <p:sldIdLst>
-    <p:sldId xmlns:r="http://schemas.openxmlformats.org/officeDocument/2006/relationships" id="256" r:id="R91eca870086e424f"/>
-    <p:sldId xmlns:r="http://schemas.openxmlformats.org/officeDocument/2006/relationships" id="257" r:id="R7cd793fea8db4922"/>
-    <p:sldId xmlns:r="http://schemas.openxmlformats.org/officeDocument/2006/relationships" id="258" r:id="Rf3098d49a0f3458e"/>
-    <p:sldId xmlns:r="http://schemas.openxmlformats.org/officeDocument/2006/relationships" id="259" r:id="R18fb6fea776c4979"/>
-    <p:sldId xmlns:r="http://schemas.openxmlformats.org/officeDocument/2006/relationships" id="260" r:id="R1f9156865a364a70"/>
-    <p:sldId xmlns:r="http://schemas.openxmlformats.org/officeDocument/2006/relationships" id="261" r:id="R64ee601f77304c52"/>
+    <p:sldId xmlns:r="http://schemas.openxmlformats.org/officeDocument/2006/relationships" id="256" r:id="R444219bc222c426e"/>
+    <p:sldId xmlns:r="http://schemas.openxmlformats.org/officeDocument/2006/relationships" id="257" r:id="Rbe0f3af9ee564d25"/>
+    <p:sldId xmlns:r="http://schemas.openxmlformats.org/officeDocument/2006/relationships" id="258" r:id="Ra69b0fa83b6145ef"/>
+    <p:sldId xmlns:r="http://schemas.openxmlformats.org/officeDocument/2006/relationships" id="259" r:id="Rd61d83991d2448d1"/>
+    <p:sldId xmlns:r="http://schemas.openxmlformats.org/officeDocument/2006/relationships" id="260" r:id="Rca1806f00b5049c0"/>
+    <p:sldId xmlns:r="http://schemas.openxmlformats.org/officeDocument/2006/relationships" id="261" r:id="Rd68f908e27974cbe"/>
   </p:sldIdLst>
   <p:sldSz cx="12192000" cy="6858000"/>
   <p:notesSz cx="6858000" cy="9144000"/>
@@ -532,7 +532,7 @@
           <a:lstStyle xmlns:a="http://schemas.openxmlformats.org/drawingml/2006/main"/>
           <a:p xmlns:a="http://schemas.openxmlformats.org/drawingml/2006/main">
             <a:r>
-              <a:t>0:12–0:27 先讲结果：48.72% 到 6.25% 的既有评测口径、8 个强制故障变体、14 条证据声明；新增本地真实执行、Agent DAG、增量因果重算与 66 项测试。</a:t>
+              <a:t>0:12–0:27 先讲结果：48.72% 到 6.25% 的既有评测口径、8 个强制故障变体、14 条证据声明；Manager 会按证据自由组合 Agent/Skill 并编译为任务 DAG，当前 66 项测试全绿。</a:t>
             </a:r>
           </a:p>
           <a:p xmlns:a="http://schemas.openxmlformats.org/drawingml/2006/main">
@@ -548,6 +548,11 @@
           <a:p xmlns:a="http://schemas.openxmlformats.org/drawingml/2006/main">
             <a:r>
               <a:t>- Internal: tests/ (unittest collection: 66)</a:t>
+            </a:r>
+          </a:p>
+          <a:p xmlns:a="http://schemas.openxmlformats.org/drawingml/2006/main">
+            <a:r>
+              <a:t>- Internal: evidence/local-controller-evidence.json</a:t>
             </a:r>
           </a:p>
         </p:txBody>
@@ -617,7 +622,7 @@
           <a:lstStyle xmlns:a="http://schemas.openxmlformats.org/drawingml/2006/main"/>
           <a:p xmlns:a="http://schemas.openxmlformats.org/drawingml/2006/main">
             <a:r>
-              <a:t>0:27–0:43 现场重点：Controller 用 Popen 启动真实 Worker 子进程。点击失败后，#01 的 PID 结束，#02 接管；事件落 SQLite Matrix。官方 AgentTeams/Matrix 仍写 pending。</a:t>
+              <a:t>0:27–0:43 现场重点：Controller 用 Popen 启动真实 Worker 子进程；PatchTournament 让 4 个候选在同一故障族上竞争，胜者由 Worker 结果写入 SQLite Matrix。官方 AgentTeams/Matrix 仍写 pending。</a:t>
             </a:r>
           </a:p>
           <a:p xmlns:a="http://schemas.openxmlformats.org/drawingml/2006/main">
@@ -637,7 +642,7 @@
           </a:p>
           <a:p xmlns:a="http://schemas.openxmlformats.org/drawingml/2006/main">
             <a:r>
-              <a:t>- Internal: deploy/infra-boundaries.json</a:t>
+              <a:t>- Internal: evidence/local-controller-evidence.json</a:t>
             </a:r>
           </a:p>
         </p:txBody>
@@ -975,7 +980,7 @@
   </p:cSld>
   <p:clrMap bg1="lt1" tx1="dk1" bg2="lt2" tx2="dk2" accent1="accent1" accent2="accent2" accent3="accent3" accent4="accent4" accent5="accent5" accent6="accent6" hlink="hlink" folHlink="folHlink"/>
   <p:sldLayoutIdLst>
-    <p:sldLayoutId xmlns:r="http://schemas.openxmlformats.org/officeDocument/2006/relationships" id="2147483649" r:id="Ra208074a65614cdb"/>
+    <p:sldLayoutId xmlns:r="http://schemas.openxmlformats.org/officeDocument/2006/relationships" id="2147483649" r:id="Rf67bfc5106314cb1"/>
   </p:sldLayoutIdLst>
   <p:txStyles>
     <p:titleStyle>
@@ -2866,7 +2871,7 @@
                   <a:srgbClr val="101828"/>
                 </a:solidFill>
               </a:rPr>
-              <a:t>本地 Controller 拉起真实子进程，失败后切换到不同 Worker 实例。</a:t>
+              <a:t>本地 Controller 拉起真实子进程；4 个候选在同一故障族上竞争。</a:t>
             </a:r>
           </a:p>
         </p:txBody>
@@ -4160,7 +4165,7 @@
                   <a:srgbClr val="64748B"/>
                 </a:solidFill>
               </a:rPr>
-              <a:t>Manager 根据证据自由组合 Agent/Skill；新证据触发增量因果重算，本地 Controller 记录 PID、duration_ms、SQLite Matrix，官方 AgentTeams 仍明确标 pending。</a:t>
+              <a:t>Manager 根据证据自由组合并编译 DAG；本地 Controller 记录 PID、duration_ms、SQLite Matrix 与 patch_tournament_completed，官方 AgentTeams 仍明确标 pending。</a:t>
             </a:r>
           </a:p>
         </p:txBody>
@@ -6000,7 +6005,7 @@
                   <a:srgbClr val="64748B"/>
                 </a:solidFill>
               </a:rPr>
-              <a:t>Trace、checks、RiskGate、run-manifest 与 DSSE 共同绑定同一 run_id。</a:t>
+              <a:t>Trace、checks、RiskGate、patch_tournament_completed、run-manifest 与 DSSE 共同绑定同一 run_id。</a:t>
             </a:r>
           </a:p>
         </p:txBody>
@@ -7084,7 +7089,7 @@
                   <a:srgbClr val="64748B"/>
                 </a:solidFill>
               </a:rPr>
-              <a:t>Worker 失败重派｜增量因果重算｜旧审批失效｜Badcase 拒答</a:t>
+              <a:t>Worker 重派｜增量重算｜4 方案竞赛｜旧审批失效｜Badcase 拒答</a:t>
             </a:r>
           </a:p>
         </p:txBody>
@@ -9198,7 +9203,7 @@
                   <a:srgbClr val="101828"/>
                 </a:solidFill>
               </a:rPr>
-              <a:t>repair-cockpit/ · 三个动作按钮 + Badcase 拒答</a:t>
+              <a:t>repair-cockpit/ · 现场按钮 + 4 方案竞赛 + Badcase 拒答</a:t>
             </a:r>
           </a:p>
         </p:txBody>

</xml_diff>

<commit_message>
fix: align demo recovery and defense materials
</commit_message>
<xml_diff>
--- a/submission/ChronosFix_90秒答辩版.pptx
+++ b/submission/ChronosFix_90秒答辩版.pptx
@@ -2,18 +2,18 @@
 <file path=ppt/presentation.xml><?xml version="1.0" encoding="utf-8"?>
 <p:presentation xmlns:p="http://schemas.openxmlformats.org/presentationml/2006/main">
   <p:sldMasterIdLst>
-    <p:sldMasterId xmlns:r="http://schemas.openxmlformats.org/officeDocument/2006/relationships" id="2147483648" r:id="R40daaee0e70e4c4e"/>
+    <p:sldMasterId xmlns:r="http://schemas.openxmlformats.org/officeDocument/2006/relationships" id="2147483648" r:id="R6a657cf8d6ee407a"/>
   </p:sldMasterIdLst>
   <p:notesMasterIdLst>
-    <p:notesMasterId xmlns:r="http://schemas.openxmlformats.org/officeDocument/2006/relationships" r:id="R2c4539afd7a24913"/>
+    <p:notesMasterId xmlns:r="http://schemas.openxmlformats.org/officeDocument/2006/relationships" r:id="Rfdf465bad989466e"/>
   </p:notesMasterIdLst>
   <p:sldIdLst>
-    <p:sldId xmlns:r="http://schemas.openxmlformats.org/officeDocument/2006/relationships" id="256" r:id="R444219bc222c426e"/>
-    <p:sldId xmlns:r="http://schemas.openxmlformats.org/officeDocument/2006/relationships" id="257" r:id="Rbe0f3af9ee564d25"/>
-    <p:sldId xmlns:r="http://schemas.openxmlformats.org/officeDocument/2006/relationships" id="258" r:id="Ra69b0fa83b6145ef"/>
-    <p:sldId xmlns:r="http://schemas.openxmlformats.org/officeDocument/2006/relationships" id="259" r:id="Rd61d83991d2448d1"/>
-    <p:sldId xmlns:r="http://schemas.openxmlformats.org/officeDocument/2006/relationships" id="260" r:id="Rca1806f00b5049c0"/>
-    <p:sldId xmlns:r="http://schemas.openxmlformats.org/officeDocument/2006/relationships" id="261" r:id="Rd68f908e27974cbe"/>
+    <p:sldId xmlns:r="http://schemas.openxmlformats.org/officeDocument/2006/relationships" id="256" r:id="R65e20ee9337248cd"/>
+    <p:sldId xmlns:r="http://schemas.openxmlformats.org/officeDocument/2006/relationships" id="257" r:id="Rc1b50622f4a8420c"/>
+    <p:sldId xmlns:r="http://schemas.openxmlformats.org/officeDocument/2006/relationships" id="258" r:id="R9ce30ae7a00c4255"/>
+    <p:sldId xmlns:r="http://schemas.openxmlformats.org/officeDocument/2006/relationships" id="259" r:id="Ree39a72528c2468a"/>
+    <p:sldId xmlns:r="http://schemas.openxmlformats.org/officeDocument/2006/relationships" id="260" r:id="R1979901f664843fd"/>
+    <p:sldId xmlns:r="http://schemas.openxmlformats.org/officeDocument/2006/relationships" id="261" r:id="R2eddd90e7cd14819"/>
   </p:sldIdLst>
   <p:sldSz cx="12192000" cy="6858000"/>
   <p:notesSz cx="6858000" cy="9144000"/>
@@ -980,7 +980,7 @@
   </p:cSld>
   <p:clrMap bg1="lt1" tx1="dk1" bg2="lt2" tx2="dk2" accent1="accent1" accent2="accent2" accent3="accent3" accent4="accent4" accent5="accent5" accent6="accent6" hlink="hlink" folHlink="folHlink"/>
   <p:sldLayoutIdLst>
-    <p:sldLayoutId xmlns:r="http://schemas.openxmlformats.org/officeDocument/2006/relationships" id="2147483649" r:id="Rf67bfc5106314cb1"/>
+    <p:sldLayoutId xmlns:r="http://schemas.openxmlformats.org/officeDocument/2006/relationships" id="2147483649" r:id="R5d0e5471c83a4dbb"/>
   </p:sldLayoutIdLst>
   <p:txStyles>
     <p:titleStyle>
@@ -7668,7 +7668,7 @@
                   <a:srgbClr val="FFFFFF"/>
                 </a:solidFill>
               </a:rPr>
-              <a:t>不支持根因 / 来源冲突 → abstain 或 indeterminate</a:t>
+              <a:t>不可归因 / 来源冲突</a:t>
             </a:r>
           </a:p>
         </p:txBody>

</xml_diff>